<commit_message>
docs(final): record release verification
</commit_message>
<xml_diff>
--- a/docs/presentation/teamnova-final-sprint5.pptx
+++ b/docs/presentation/teamnova-final-sprint5.pptx
@@ -14,6 +14,7 @@
     <p:sldId id="262" r:id="rId8"/>
     <p:sldId id="263" r:id="rId9"/>
     <p:sldId id="264" r:id="rId10"/>
+    <p:sldId id="265" r:id="rId16"/>
   </p:sldIdLst>
   <p:notesMasterIdLst>
     <p:notesMasterId r:id="rId11"/>
@@ -534,6 +535,94 @@
             <a:fld id="{F7021451-1387-4CA6-816F-3879F97B5CBC}" type="slidenum">
               <a:rPr lang="en-US"/>
               <a:t>1</a:t>
+            </a:fld>
+            <a:endParaRPr lang="en-US"/>
+          </a:p>
+        </p:txBody>
+      </p:sp>
+    </p:spTree>
+    <p:extLst>
+      <p:ext uri="{BB962C8B-B14F-4D97-AF65-F5344CB8AC3E}">
+        <p14:creationId xmlns:p14="http://schemas.microsoft.com/office/powerpoint/2010/main" val="1024086991"/>
+      </p:ext>
+    </p:extLst>
+  </p:cSld>
+  <p:clrMapOvr>
+    <a:masterClrMapping/>
+  </p:clrMapOvr>
+</p:notes>
+</file>
+
+<file path=ppt/notesSlides/notesSlide10.xml><?xml version="1.0" encoding="utf-8"?>
+<p:notes xmlns:a="http://schemas.openxmlformats.org/drawingml/2006/main" xmlns:r="http://schemas.openxmlformats.org/officeDocument/2006/relationships" xmlns:p="http://schemas.openxmlformats.org/presentationml/2006/main">
+  <p:cSld>
+    <p:spTree>
+      <p:nvGrpSpPr>
+        <p:cNvPr id="1" name=""/>
+        <p:cNvGrpSpPr/>
+        <p:nvPr/>
+      </p:nvGrpSpPr>
+      <p:grpSpPr>
+        <a:xfrm>
+          <a:off x="0" y="0"/>
+          <a:ext cx="0" cy="0"/>
+          <a:chOff x="0" y="0"/>
+          <a:chExt cx="0" cy="0"/>
+        </a:xfrm>
+      </p:grpSpPr>
+      <p:sp>
+        <p:nvSpPr>
+          <p:cNvPr id="2" name="Slide Image Placeholder 1"/>
+          <p:cNvSpPr>
+            <a:spLocks noGrp="1" noRot="1" noChangeAspect="1"/>
+          </p:cNvSpPr>
+          <p:nvPr>
+            <p:ph type="sldImg"/>
+          </p:nvPr>
+        </p:nvSpPr>
+        <p:spPr/>
+      </p:sp>
+      <p:sp>
+        <p:nvSpPr>
+          <p:cNvPr id="3" name="Notes Placeholder 2"/>
+          <p:cNvSpPr>
+            <a:spLocks noGrp="1"/>
+          </p:cNvSpPr>
+          <p:nvPr>
+            <p:ph type="body" idx="1"/>
+          </p:nvPr>
+        </p:nvSpPr>
+        <p:spPr/>
+        <p:txBody>
+          <a:bodyPr/>
+          <a:lstStyle/>
+          <a:p>
+            <a:r>
+              <a:rPr lang="en-US" dirty="0"/>
+              <a:t/>
+            </a:r>
+            <a:endParaRPr lang="en-US" dirty="0"/>
+          </a:p>
+        </p:txBody>
+      </p:sp>
+      <p:sp>
+        <p:nvSpPr>
+          <p:cNvPr id="4" name="Slide Number Placeholder 3"/>
+          <p:cNvSpPr>
+            <a:spLocks noGrp="1"/>
+          </p:cNvSpPr>
+          <p:nvPr>
+            <p:ph type="sldNum" sz="quarter" idx="10"/>
+          </p:nvPr>
+        </p:nvSpPr>
+        <p:spPr/>
+        <p:txBody>
+          <a:bodyPr/>
+          <a:lstStyle/>
+          <a:p>
+            <a:fld id="{F7021451-1387-4CA6-816F-3879F97B5CBC}" type="slidenum">
+              <a:rPr lang="en-US"/>
+              <a:t>10</a:t>
             </a:fld>
             <a:endParaRPr lang="en-US"/>
           </a:p>
@@ -2779,6 +2868,779 @@
 </p:sld>
 </file>
 
+<file path=ppt/slides/slide10.xml><?xml version="1.0" encoding="utf-8"?>
+<p:sld xmlns:a="http://schemas.openxmlformats.org/drawingml/2006/main" xmlns:r="http://schemas.openxmlformats.org/officeDocument/2006/relationships" xmlns:p="http://schemas.openxmlformats.org/presentationml/2006/main">
+  <p:cSld name="Slide 9">
+    <p:bg>
+      <p:bgPr>
+        <a:solidFill>
+          <a:srgbClr val="F4F5F7"/>
+        </a:solidFill>
+      </p:bgPr>
+    </p:bg>
+    <p:spTree>
+      <p:nvGrpSpPr>
+        <p:cNvPr id="1" name=""/>
+        <p:cNvGrpSpPr/>
+        <p:nvPr/>
+      </p:nvGrpSpPr>
+      <p:grpSpPr>
+        <a:xfrm>
+          <a:off x="0" y="0"/>
+          <a:ext cx="0" cy="0"/>
+          <a:chOff x="0" y="0"/>
+          <a:chExt cx="0" cy="0"/>
+        </a:xfrm>
+      </p:grpSpPr>
+      <p:sp>
+        <p:nvSpPr>
+          <p:cNvPr id="2" name="Text 0"/>
+          <p:cNvSpPr/>
+          <p:nvPr/>
+        </p:nvSpPr>
+        <p:spPr>
+          <a:xfrm>
+            <a:off x="713232" y="658368"/>
+            <a:ext cx="4206240" cy="256032"/>
+          </a:xfrm>
+          <a:prstGeom prst="rect">
+            <a:avLst/>
+          </a:prstGeom>
+          <a:noFill/>
+          <a:ln/>
+        </p:spPr>
+        <p:txBody>
+          <a:bodyPr wrap="square" lIns="0" tIns="0" rIns="0" bIns="0" rtlCol="0" anchor="ctr"/>
+          <a:lstStyle/>
+          <a:p>
+            <a:pPr indent="0" marL="0">
+              <a:buNone/>
+            </a:pPr>
+            <a:r>
+              <a:rPr lang="en-US" sz="950" b="1" dirty="0">
+                <a:solidFill>
+                  <a:srgbClr val="2477B8"/>
+                </a:solidFill>
+                <a:latin typeface="Aptos" pitchFamily="34" charset="0"/>
+                <a:ea typeface="Aptos" pitchFamily="34" charset="-122"/>
+                <a:cs typeface="Aptos" pitchFamily="34" charset="-120"/>
+              </a:rPr>
+              <a:t>ФИНАЛЬНЫЙ GATE</a:t>
+            </a:r>
+            <a:endParaRPr lang="en-US" sz="950" dirty="0"/>
+          </a:p>
+        </p:txBody>
+      </p:sp>
+      <p:sp>
+        <p:nvSpPr>
+          <p:cNvPr id="3" name="Text 1"/>
+          <p:cNvSpPr/>
+          <p:nvPr/>
+        </p:nvSpPr>
+        <p:spPr>
+          <a:xfrm>
+            <a:off x="685800" y="960120"/>
+            <a:ext cx="7132320" cy="822960"/>
+          </a:xfrm>
+          <a:prstGeom prst="rect">
+            <a:avLst/>
+          </a:prstGeom>
+          <a:noFill/>
+          <a:ln/>
+        </p:spPr>
+        <p:txBody>
+          <a:bodyPr wrap="square" lIns="0" tIns="0" rIns="0" bIns="0" rtlCol="0" anchor="ctr">
+            <a:normAutofit/>
+          </a:bodyPr>
+          <a:lstStyle/>
+          <a:p>
+            <a:pPr indent="0" marL="0">
+              <a:buNone/>
+            </a:pPr>
+            <a:r>
+              <a:rPr lang="en-US" sz="2800" b="1" dirty="0">
+                <a:solidFill>
+                  <a:srgbClr val="2D313A"/>
+                </a:solidFill>
+                <a:latin typeface="Aptos Display" pitchFamily="34" charset="0"/>
+                <a:ea typeface="Aptos Display" pitchFamily="34" charset="-122"/>
+                <a:cs typeface="Aptos Display" pitchFamily="34" charset="-120"/>
+              </a:rPr>
+              <a:t>Проверка перед сдачей</a:t>
+            </a:r>
+            <a:endParaRPr lang="en-US" sz="2800" dirty="0"/>
+          </a:p>
+        </p:txBody>
+      </p:sp>
+      <p:sp>
+        <p:nvSpPr>
+          <p:cNvPr id="4" name="Text 2"/>
+          <p:cNvSpPr/>
+          <p:nvPr/>
+        </p:nvSpPr>
+        <p:spPr>
+          <a:xfrm>
+            <a:off x="713232" y="1783080"/>
+            <a:ext cx="6492240" cy="566928"/>
+          </a:xfrm>
+          <a:prstGeom prst="rect">
+            <a:avLst/>
+          </a:prstGeom>
+          <a:noFill/>
+          <a:ln/>
+        </p:spPr>
+        <p:txBody>
+          <a:bodyPr wrap="square" lIns="127" tIns="127" rIns="127" bIns="127" rtlCol="0" anchor="ctr">
+            <a:normAutofit/>
+          </a:bodyPr>
+          <a:lstStyle/>
+          <a:p>
+            <a:pPr indent="0" marL="0">
+              <a:buNone/>
+            </a:pPr>
+            <a:r>
+              <a:rPr lang="en-US" sz="1250" dirty="0">
+                <a:solidFill>
+                  <a:srgbClr val="747B86"/>
+                </a:solidFill>
+                <a:latin typeface="Aptos" pitchFamily="34" charset="0"/>
+                <a:ea typeface="Aptos" pitchFamily="34" charset="-122"/>
+                <a:cs typeface="Aptos" pitchFamily="34" charset="-120"/>
+              </a:rPr>
+              <a:t>Финальная версия проверяется двумя автоматическими прогонами и двумя ручными MVP-cycle.</a:t>
+            </a:r>
+            <a:endParaRPr lang="en-US" sz="1250" dirty="0"/>
+          </a:p>
+        </p:txBody>
+      </p:sp>
+      <p:sp>
+        <p:nvSpPr>
+          <p:cNvPr id="5" name="Shape 3"/>
+          <p:cNvSpPr/>
+          <p:nvPr/>
+        </p:nvSpPr>
+        <p:spPr>
+          <a:xfrm>
+            <a:off x="822960" y="2423160"/>
+            <a:ext cx="4754880" cy="987552"/>
+          </a:xfrm>
+          <a:prstGeom prst="roundRect">
+            <a:avLst>
+              <a:gd name="adj" fmla="val 7407"/>
+            </a:avLst>
+          </a:prstGeom>
+          <a:solidFill>
+            <a:srgbClr val="FFFFFF"/>
+          </a:solidFill>
+          <a:ln w="12700">
+            <a:solidFill>
+              <a:srgbClr val="DDE1E6"/>
+            </a:solidFill>
+            <a:prstDash val="solid"/>
+          </a:ln>
+        </p:spPr>
+      </p:sp>
+      <p:sp>
+        <p:nvSpPr>
+          <p:cNvPr id="6" name="Shape 4"/>
+          <p:cNvSpPr/>
+          <p:nvPr/>
+        </p:nvSpPr>
+        <p:spPr>
+          <a:xfrm>
+            <a:off x="822960" y="2423160"/>
+            <a:ext cx="73152" cy="987552"/>
+          </a:xfrm>
+          <a:prstGeom prst="rect">
+            <a:avLst/>
+          </a:prstGeom>
+          <a:solidFill>
+            <a:srgbClr val="2F9B66"/>
+          </a:solidFill>
+          <a:ln w="12700">
+            <a:solidFill>
+              <a:srgbClr val="2F9B66"/>
+            </a:solidFill>
+            <a:prstDash val="solid"/>
+          </a:ln>
+        </p:spPr>
+      </p:sp>
+      <p:sp>
+        <p:nvSpPr>
+          <p:cNvPr id="7" name="Text 5"/>
+          <p:cNvSpPr/>
+          <p:nvPr/>
+        </p:nvSpPr>
+        <p:spPr>
+          <a:xfrm>
+            <a:off x="1024128" y="2569464"/>
+            <a:ext cx="4370832" cy="310896"/>
+          </a:xfrm>
+          <a:prstGeom prst="rect">
+            <a:avLst/>
+          </a:prstGeom>
+          <a:noFill/>
+          <a:ln/>
+        </p:spPr>
+        <p:txBody>
+          <a:bodyPr wrap="square" lIns="0" tIns="0" rIns="0" bIns="0" rtlCol="0" anchor="ctr">
+            <a:normAutofit/>
+          </a:bodyPr>
+          <a:lstStyle/>
+          <a:p>
+            <a:pPr indent="0" marL="0">
+              <a:buNone/>
+            </a:pPr>
+            <a:r>
+              <a:rPr lang="en-US" sz="1400" b="1" dirty="0">
+                <a:solidFill>
+                  <a:srgbClr val="2D313A"/>
+                </a:solidFill>
+                <a:latin typeface="Aptos Display" pitchFamily="34" charset="0"/>
+                <a:ea typeface="Aptos Display" pitchFamily="34" charset="-122"/>
+                <a:cs typeface="Aptos Display" pitchFamily="34" charset="-120"/>
+              </a:rPr>
+              <a:t>MVP-cycle</a:t>
+            </a:r>
+            <a:endParaRPr lang="en-US" sz="1400" dirty="0"/>
+          </a:p>
+        </p:txBody>
+      </p:sp>
+      <p:sp>
+        <p:nvSpPr>
+          <p:cNvPr id="8" name="Text 6"/>
+          <p:cNvSpPr/>
+          <p:nvPr/>
+        </p:nvSpPr>
+        <p:spPr>
+          <a:xfrm>
+            <a:off x="1024128" y="2953512"/>
+            <a:ext cx="4370832" cy="347472"/>
+          </a:xfrm>
+          <a:prstGeom prst="rect">
+            <a:avLst/>
+          </a:prstGeom>
+          <a:noFill/>
+          <a:ln/>
+        </p:spPr>
+        <p:txBody>
+          <a:bodyPr wrap="square" lIns="0" tIns="0" rIns="0" bIns="0" rtlCol="0" anchor="ctr">
+            <a:normAutofit/>
+          </a:bodyPr>
+          <a:lstStyle/>
+          <a:p>
+            <a:pPr indent="0" marL="0">
+              <a:buNone/>
+            </a:pPr>
+            <a:r>
+              <a:rPr lang="en-US" sz="950" dirty="0">
+                <a:solidFill>
+                  <a:srgbClr val="747B86"/>
+                </a:solidFill>
+                <a:latin typeface="Aptos" pitchFamily="34" charset="0"/>
+                <a:ea typeface="Aptos" pitchFamily="34" charset="-122"/>
+                <a:cs typeface="Aptos" pitchFamily="34" charset="-120"/>
+              </a:rPr>
+              <a:t>User A создает проект, User B находит и подает заявку, User A принимает или отклоняет.</a:t>
+            </a:r>
+            <a:endParaRPr lang="en-US" sz="950" dirty="0"/>
+          </a:p>
+        </p:txBody>
+      </p:sp>
+      <p:sp>
+        <p:nvSpPr>
+          <p:cNvPr id="9" name="Shape 7"/>
+          <p:cNvSpPr/>
+          <p:nvPr/>
+        </p:nvSpPr>
+        <p:spPr>
+          <a:xfrm>
+            <a:off x="6172200" y="2423160"/>
+            <a:ext cx="4754880" cy="987552"/>
+          </a:xfrm>
+          <a:prstGeom prst="roundRect">
+            <a:avLst>
+              <a:gd name="adj" fmla="val 7407"/>
+            </a:avLst>
+          </a:prstGeom>
+          <a:solidFill>
+            <a:srgbClr val="FFFFFF"/>
+          </a:solidFill>
+          <a:ln w="12700">
+            <a:solidFill>
+              <a:srgbClr val="DDE1E6"/>
+            </a:solidFill>
+            <a:prstDash val="solid"/>
+          </a:ln>
+        </p:spPr>
+      </p:sp>
+      <p:sp>
+        <p:nvSpPr>
+          <p:cNvPr id="10" name="Shape 8"/>
+          <p:cNvSpPr/>
+          <p:nvPr/>
+        </p:nvSpPr>
+        <p:spPr>
+          <a:xfrm>
+            <a:off x="6172200" y="2423160"/>
+            <a:ext cx="73152" cy="987552"/>
+          </a:xfrm>
+          <a:prstGeom prst="rect">
+            <a:avLst/>
+          </a:prstGeom>
+          <a:solidFill>
+            <a:srgbClr val="48A7FF"/>
+          </a:solidFill>
+          <a:ln w="12700">
+            <a:solidFill>
+              <a:srgbClr val="48A7FF"/>
+            </a:solidFill>
+            <a:prstDash val="solid"/>
+          </a:ln>
+        </p:spPr>
+      </p:sp>
+      <p:sp>
+        <p:nvSpPr>
+          <p:cNvPr id="11" name="Text 9"/>
+          <p:cNvSpPr/>
+          <p:nvPr/>
+        </p:nvSpPr>
+        <p:spPr>
+          <a:xfrm>
+            <a:off x="6373368" y="2569464"/>
+            <a:ext cx="4370832" cy="310896"/>
+          </a:xfrm>
+          <a:prstGeom prst="rect">
+            <a:avLst/>
+          </a:prstGeom>
+          <a:noFill/>
+          <a:ln/>
+        </p:spPr>
+        <p:txBody>
+          <a:bodyPr wrap="square" lIns="0" tIns="0" rIns="0" bIns="0" rtlCol="0" anchor="ctr">
+            <a:normAutofit/>
+          </a:bodyPr>
+          <a:lstStyle/>
+          <a:p>
+            <a:pPr indent="0" marL="0">
+              <a:buNone/>
+            </a:pPr>
+            <a:r>
+              <a:rPr lang="en-US" sz="1400" b="1" dirty="0">
+                <a:solidFill>
+                  <a:srgbClr val="2D313A"/>
+                </a:solidFill>
+                <a:latin typeface="Aptos Display" pitchFamily="34" charset="0"/>
+                <a:ea typeface="Aptos Display" pitchFamily="34" charset="-122"/>
+                <a:cs typeface="Aptos Display" pitchFamily="34" charset="-120"/>
+              </a:rPr>
+              <a:t>Автотесты</a:t>
+            </a:r>
+            <a:endParaRPr lang="en-US" sz="1400" dirty="0"/>
+          </a:p>
+        </p:txBody>
+      </p:sp>
+      <p:sp>
+        <p:nvSpPr>
+          <p:cNvPr id="12" name="Text 10"/>
+          <p:cNvSpPr/>
+          <p:nvPr/>
+        </p:nvSpPr>
+        <p:spPr>
+          <a:xfrm>
+            <a:off x="6373368" y="2953512"/>
+            <a:ext cx="4370832" cy="347472"/>
+          </a:xfrm>
+          <a:prstGeom prst="rect">
+            <a:avLst/>
+          </a:prstGeom>
+          <a:noFill/>
+          <a:ln/>
+        </p:spPr>
+        <p:txBody>
+          <a:bodyPr wrap="square" lIns="0" tIns="0" rIns="0" bIns="0" rtlCol="0" anchor="ctr">
+            <a:normAutofit/>
+          </a:bodyPr>
+          <a:lstStyle/>
+          <a:p>
+            <a:pPr indent="0" marL="0">
+              <a:buNone/>
+            </a:pPr>
+            <a:r>
+              <a:rPr lang="en-US" sz="950" dirty="0">
+                <a:solidFill>
+                  <a:srgbClr val="747B86"/>
+                </a:solidFill>
+                <a:latin typeface="Aptos" pitchFamily="34" charset="0"/>
+                <a:ea typeface="Aptos" pitchFamily="34" charset="-122"/>
+                <a:cs typeface="Aptos" pitchFamily="34" charset="-120"/>
+              </a:rPr>
+              <a:t>Frontend, backend, build, backend build, lint и db generate без новых регрессий.</a:t>
+            </a:r>
+            <a:endParaRPr lang="en-US" sz="950" dirty="0"/>
+          </a:p>
+        </p:txBody>
+      </p:sp>
+      <p:sp>
+        <p:nvSpPr>
+          <p:cNvPr id="13" name="Shape 11"/>
+          <p:cNvSpPr/>
+          <p:nvPr/>
+        </p:nvSpPr>
+        <p:spPr>
+          <a:xfrm>
+            <a:off x="822960" y="3840480"/>
+            <a:ext cx="4754880" cy="987552"/>
+          </a:xfrm>
+          <a:prstGeom prst="roundRect">
+            <a:avLst>
+              <a:gd name="adj" fmla="val 7407"/>
+            </a:avLst>
+          </a:prstGeom>
+          <a:solidFill>
+            <a:srgbClr val="FFFFFF"/>
+          </a:solidFill>
+          <a:ln w="12700">
+            <a:solidFill>
+              <a:srgbClr val="DDE1E6"/>
+            </a:solidFill>
+            <a:prstDash val="solid"/>
+          </a:ln>
+        </p:spPr>
+      </p:sp>
+      <p:sp>
+        <p:nvSpPr>
+          <p:cNvPr id="14" name="Shape 12"/>
+          <p:cNvSpPr/>
+          <p:nvPr/>
+        </p:nvSpPr>
+        <p:spPr>
+          <a:xfrm>
+            <a:off x="822960" y="3840480"/>
+            <a:ext cx="73152" cy="987552"/>
+          </a:xfrm>
+          <a:prstGeom prst="rect">
+            <a:avLst/>
+          </a:prstGeom>
+          <a:solidFill>
+            <a:srgbClr val="DE7D2A"/>
+          </a:solidFill>
+          <a:ln w="12700">
+            <a:solidFill>
+              <a:srgbClr val="DE7D2A"/>
+            </a:solidFill>
+            <a:prstDash val="solid"/>
+          </a:ln>
+        </p:spPr>
+      </p:sp>
+      <p:sp>
+        <p:nvSpPr>
+          <p:cNvPr id="15" name="Text 13"/>
+          <p:cNvSpPr/>
+          <p:nvPr/>
+        </p:nvSpPr>
+        <p:spPr>
+          <a:xfrm>
+            <a:off x="1024128" y="3986784"/>
+            <a:ext cx="4370832" cy="310896"/>
+          </a:xfrm>
+          <a:prstGeom prst="rect">
+            <a:avLst/>
+          </a:prstGeom>
+          <a:noFill/>
+          <a:ln/>
+        </p:spPr>
+        <p:txBody>
+          <a:bodyPr wrap="square" lIns="0" tIns="0" rIns="0" bIns="0" rtlCol="0" anchor="ctr">
+            <a:normAutofit/>
+          </a:bodyPr>
+          <a:lstStyle/>
+          <a:p>
+            <a:pPr indent="0" marL="0">
+              <a:buNone/>
+            </a:pPr>
+            <a:r>
+              <a:rPr lang="en-US" sz="1400" b="1" dirty="0">
+                <a:solidFill>
+                  <a:srgbClr val="2D313A"/>
+                </a:solidFill>
+                <a:latin typeface="Aptos Display" pitchFamily="34" charset="0"/>
+                <a:ea typeface="Aptos Display" pitchFamily="34" charset="-122"/>
+                <a:cs typeface="Aptos Display" pitchFamily="34" charset="-120"/>
+              </a:rPr>
+              <a:t>Маршруты</a:t>
+            </a:r>
+            <a:endParaRPr lang="en-US" sz="1400" dirty="0"/>
+          </a:p>
+        </p:txBody>
+      </p:sp>
+      <p:sp>
+        <p:nvSpPr>
+          <p:cNvPr id="16" name="Text 14"/>
+          <p:cNvSpPr/>
+          <p:nvPr/>
+        </p:nvSpPr>
+        <p:spPr>
+          <a:xfrm>
+            <a:off x="1024128" y="4370832"/>
+            <a:ext cx="4370832" cy="347472"/>
+          </a:xfrm>
+          <a:prstGeom prst="rect">
+            <a:avLst/>
+          </a:prstGeom>
+          <a:noFill/>
+          <a:ln/>
+        </p:spPr>
+        <p:txBody>
+          <a:bodyPr wrap="square" lIns="0" tIns="0" rIns="0" bIns="0" rtlCol="0" anchor="ctr">
+            <a:normAutofit/>
+          </a:bodyPr>
+          <a:lstStyle/>
+          <a:p>
+            <a:pPr indent="0" marL="0">
+              <a:buNone/>
+            </a:pPr>
+            <a:r>
+              <a:rPr lang="en-US" sz="950" dirty="0">
+                <a:solidFill>
+                  <a:srgbClr val="747B86"/>
+                </a:solidFill>
+                <a:latin typeface="Aptos" pitchFamily="34" charset="0"/>
+                <a:ea typeface="Aptos" pitchFamily="34" charset="-122"/>
+                <a:cs typeface="Aptos" pitchFamily="34" charset="-120"/>
+              </a:rPr>
+              <a:t>Direct refresh: /home, /profile, /search, /requests, /projects/new.</a:t>
+            </a:r>
+            <a:endParaRPr lang="en-US" sz="950" dirty="0"/>
+          </a:p>
+        </p:txBody>
+      </p:sp>
+      <p:sp>
+        <p:nvSpPr>
+          <p:cNvPr id="17" name="Shape 15"/>
+          <p:cNvSpPr/>
+          <p:nvPr/>
+        </p:nvSpPr>
+        <p:spPr>
+          <a:xfrm>
+            <a:off x="6172200" y="3840480"/>
+            <a:ext cx="4754880" cy="987552"/>
+          </a:xfrm>
+          <a:prstGeom prst="roundRect">
+            <a:avLst>
+              <a:gd name="adj" fmla="val 7407"/>
+            </a:avLst>
+          </a:prstGeom>
+          <a:solidFill>
+            <a:srgbClr val="FFFFFF"/>
+          </a:solidFill>
+          <a:ln w="12700">
+            <a:solidFill>
+              <a:srgbClr val="DDE1E6"/>
+            </a:solidFill>
+            <a:prstDash val="solid"/>
+          </a:ln>
+        </p:spPr>
+      </p:sp>
+      <p:sp>
+        <p:nvSpPr>
+          <p:cNvPr id="18" name="Shape 16"/>
+          <p:cNvSpPr/>
+          <p:nvPr/>
+        </p:nvSpPr>
+        <p:spPr>
+          <a:xfrm>
+            <a:off x="6172200" y="3840480"/>
+            <a:ext cx="73152" cy="987552"/>
+          </a:xfrm>
+          <a:prstGeom prst="rect">
+            <a:avLst/>
+          </a:prstGeom>
+          <a:solidFill>
+            <a:srgbClr val="D45573"/>
+          </a:solidFill>
+          <a:ln w="12700">
+            <a:solidFill>
+              <a:srgbClr val="D45573"/>
+            </a:solidFill>
+            <a:prstDash val="solid"/>
+          </a:ln>
+        </p:spPr>
+      </p:sp>
+      <p:sp>
+        <p:nvSpPr>
+          <p:cNvPr id="19" name="Text 17"/>
+          <p:cNvSpPr/>
+          <p:nvPr/>
+        </p:nvSpPr>
+        <p:spPr>
+          <a:xfrm>
+            <a:off x="6373368" y="3986784"/>
+            <a:ext cx="4370832" cy="310896"/>
+          </a:xfrm>
+          <a:prstGeom prst="rect">
+            <a:avLst/>
+          </a:prstGeom>
+          <a:noFill/>
+          <a:ln/>
+        </p:spPr>
+        <p:txBody>
+          <a:bodyPr wrap="square" lIns="0" tIns="0" rIns="0" bIns="0" rtlCol="0" anchor="ctr">
+            <a:normAutofit/>
+          </a:bodyPr>
+          <a:lstStyle/>
+          <a:p>
+            <a:pPr indent="0" marL="0">
+              <a:buNone/>
+            </a:pPr>
+            <a:r>
+              <a:rPr lang="en-US" sz="1400" b="1" dirty="0">
+                <a:solidFill>
+                  <a:srgbClr val="2D313A"/>
+                </a:solidFill>
+                <a:latin typeface="Aptos Display" pitchFamily="34" charset="0"/>
+                <a:ea typeface="Aptos Display" pitchFamily="34" charset="-122"/>
+                <a:cs typeface="Aptos Display" pitchFamily="34" charset="-120"/>
+              </a:rPr>
+              <a:t>Hosting</a:t>
+            </a:r>
+            <a:endParaRPr lang="en-US" sz="1400" dirty="0"/>
+          </a:p>
+        </p:txBody>
+      </p:sp>
+      <p:sp>
+        <p:nvSpPr>
+          <p:cNvPr id="20" name="Text 18"/>
+          <p:cNvSpPr/>
+          <p:nvPr/>
+        </p:nvSpPr>
+        <p:spPr>
+          <a:xfrm>
+            <a:off x="6373368" y="4370832"/>
+            <a:ext cx="4370832" cy="347472"/>
+          </a:xfrm>
+          <a:prstGeom prst="rect">
+            <a:avLst/>
+          </a:prstGeom>
+          <a:noFill/>
+          <a:ln/>
+        </p:spPr>
+        <p:txBody>
+          <a:bodyPr wrap="square" lIns="0" tIns="0" rIns="0" bIns="0" rtlCol="0" anchor="ctr">
+            <a:normAutofit/>
+          </a:bodyPr>
+          <a:lstStyle/>
+          <a:p>
+            <a:pPr indent="0" marL="0">
+              <a:buNone/>
+            </a:pPr>
+            <a:r>
+              <a:rPr lang="en-US" sz="950" dirty="0">
+                <a:solidFill>
+                  <a:srgbClr val="747B86"/>
+                </a:solidFill>
+                <a:latin typeface="Aptos" pitchFamily="34" charset="0"/>
+                <a:ea typeface="Aptos" pitchFamily="34" charset="-122"/>
+                <a:cs typeface="Aptos" pitchFamily="34" charset="-120"/>
+              </a:rPr>
+              <a:t>Код deployment-ready; внешний DNS/домен проверяется отдельно при наличии доступа.</a:t>
+            </a:r>
+            <a:endParaRPr lang="en-US" sz="950" dirty="0"/>
+          </a:p>
+        </p:txBody>
+      </p:sp>
+      <p:sp>
+        <p:nvSpPr>
+          <p:cNvPr id="21" name="Text 19"/>
+          <p:cNvSpPr/>
+          <p:nvPr/>
+        </p:nvSpPr>
+        <p:spPr>
+          <a:xfrm>
+            <a:off x="3977640" y="5715000"/>
+            <a:ext cx="4206240" cy="411480"/>
+          </a:xfrm>
+          <a:prstGeom prst="rect">
+            <a:avLst/>
+          </a:prstGeom>
+          <a:noFill/>
+          <a:ln/>
+        </p:spPr>
+        <p:txBody>
+          <a:bodyPr wrap="square" lIns="0" tIns="0" rIns="0" bIns="0" rtlCol="0" anchor="ctr"/>
+          <a:lstStyle/>
+          <a:p>
+            <a:pPr algn="ctr" indent="0" marL="0">
+              <a:buNone/>
+            </a:pPr>
+            <a:r>
+              <a:rPr lang="en-US" sz="2200" b="1" dirty="0">
+                <a:solidFill>
+                  <a:srgbClr val="2D313A"/>
+                </a:solidFill>
+                <a:latin typeface="Aptos Display" pitchFamily="34" charset="0"/>
+                <a:ea typeface="Aptos Display" pitchFamily="34" charset="-122"/>
+                <a:cs typeface="Aptos Display" pitchFamily="34" charset="-120"/>
+              </a:rPr>
+              <a:t>TEAMNOVA</a:t>
+            </a:r>
+            <a:endParaRPr lang="en-US" sz="2200" dirty="0"/>
+          </a:p>
+        </p:txBody>
+      </p:sp>
+      <p:sp>
+        <p:nvSpPr>
+          <p:cNvPr id="25" name="Slide Number Placeholder 0"/>
+          <p:cNvSpPr>
+            <a:spLocks noGrp="1"/>
+          </p:cNvSpPr>
+          <p:nvPr>
+            <p:ph type="sldNum" sz="quarter" idx="4294967295"/>
+          </p:nvPr>
+        </p:nvSpPr>
+        <p:spPr>
+          <a:xfrm>
+            <a:off x="11384280" y="6400800"/>
+            <a:ext cx="800000" cy="300000"/>
+          </a:xfrm>
+          <a:prstGeom prst="rect">
+            <a:avLst/>
+          </a:prstGeom>
+          <a:extLst>
+            <a:ext uri="{C572A759-6A51-4108-AA02-DFA0A04FC94B}">
+              <ma14:wrappingTextBoxFlag xmlns:ma14="http://schemas.microsoft.com/office/mac/drawingml/2011/main" val="0"/>
+            </a:ext>
+          </a:extLst>
+        </p:spPr>
+        <p:txBody>
+          <a:bodyPr/>
+          <a:lstStyle>
+            <a:lvl1pPr>
+              <a:defRPr sz="800">
+                <a:solidFill>
+                  <a:srgbClr val="8B919B"/>
+                </a:solidFill>
+              </a:defRPr>
+            </a:lvl1pPr>
+          </a:lstStyle>
+          <a:p>
+            <a:pPr algn="l"/>
+            <a:fld id="{F7021451-1387-4CA6-816F-3879F97B5CBC}" type="slidenum">
+              <a:rPr b="0" lang="en-US"/>
+              <a:t>10</a:t>
+            </a:fld>
+            <a:endParaRPr lang="en-US"/>
+          </a:p>
+        </p:txBody>
+      </p:sp>
+    </p:spTree>
+  </p:cSld>
+  <p:clrMapOvr>
+    <a:masterClrMapping/>
+  </p:clrMapOvr>
+</p:sld>
+</file>
+
 <file path=ppt/slides/slide2.xml><?xml version="1.0" encoding="utf-8"?>
 <p:sld xmlns:a="http://schemas.openxmlformats.org/drawingml/2006/main" xmlns:r="http://schemas.openxmlformats.org/officeDocument/2006/relationships" xmlns:p="http://schemas.openxmlformats.org/presentationml/2006/main">
   <p:cSld name="Slide 2">
@@ -8668,7 +9530,7 @@
                 <a:ea typeface="Aptos Display" pitchFamily="34" charset="-122"/>
                 <a:cs typeface="Aptos Display" pitchFamily="34" charset="-120"/>
               </a:rPr>
-              <a:t>MVP готов к финальной проверке и PR</a:t>
+              <a:t>MVP готов к финальной сдаче</a:t>
             </a:r>
             <a:endParaRPr lang="en-US" sz="2800" dirty="0"/>
           </a:p>
@@ -8709,7 +9571,7 @@
                 <a:ea typeface="Aptos" pitchFamily="34" charset="-122"/>
                 <a:cs typeface="Aptos" pitchFamily="34" charset="-120"/>
               </a:rPr>
-              <a:t>Сайт добит до состояния защиты: рабочий сценарий, QA-доки, release checklist и презентация.</a:t>
+              <a:t>Сайт доведен до состояния защиты: рабочий сценарий, темно-фиолетовый UI, QA-доки, release checklist и презентация.</a:t>
             </a:r>
             <a:endParaRPr lang="en-US" sz="1250" dirty="0"/>
           </a:p>
@@ -8843,7 +9705,7 @@
                 <a:ea typeface="Aptos" pitchFamily="34" charset="-122"/>
                 <a:cs typeface="Aptos" pitchFamily="34" charset="-120"/>
               </a:rPr>
-              <a:t>Auth, профиль, проекты, поиск и заявки закрывают MVP.</a:t>
+              <a:t>Auth, профиль, проекты, поиск и заявки закрывают MVP по кейсу.</a:t>
             </a:r>
             <a:endParaRPr lang="en-US" sz="950" dirty="0"/>
           </a:p>
@@ -8936,7 +9798,7 @@
                 <a:ea typeface="Aptos Display" pitchFamily="34" charset="-122"/>
                 <a:cs typeface="Aptos Display" pitchFamily="34" charset="-120"/>
               </a:rPr>
-              <a:t>Качество</a:t>
+              <a:t>Дизайн</a:t>
             </a:r>
             <a:endParaRPr lang="en-US" sz="1400" dirty="0"/>
           </a:p>
@@ -8977,7 +9839,7 @@
                 <a:ea typeface="Aptos" pitchFamily="34" charset="-122"/>
                 <a:cs typeface="Aptos" pitchFamily="34" charset="-120"/>
               </a:rPr>
-              <a:t>Добавлена regression-защита и browser smoke для демо-блокера.</a:t>
+              <a:t>Все пользовательские маршруты приведены к темно-фиолетовому Teamnova-стилю.</a:t>
             </a:r>
             <a:endParaRPr lang="en-US" sz="950" dirty="0"/>
           </a:p>
@@ -9245,7 +10107,7 @@
                 <a:ea typeface="Aptos" pitchFamily="34" charset="-122"/>
                 <a:cs typeface="Aptos" pitchFamily="34" charset="-120"/>
               </a:rPr>
-              <a:t>Дальше: commit, push, draft PR в main как production-ready базу.</a:t>
+              <a:t>Код готов к Docker/Nginx-публикации; DNS/hosting проверяется только при наличии внешнего доступа.</a:t>
             </a:r>
             <a:endParaRPr lang="en-US" sz="950" dirty="0"/>
           </a:p>

</xml_diff>